<commit_message>
Livrables : captures de l'application en ligne et liens (app + GitHub)
- 5 captures de l'app déployée (connexion, espace salarié, validation
  manager, tableau de bord, Swagger) dans docs/screenshots/.
- Mémoire : captures intégrées (Fig.13 à 17) + URL app et GitHub.
- PowerPoint : slide démo avec captures réelles + liens.
- DP : liens dépôt GitHub et application en ligne.
</commit_message>
<xml_diff>
--- a/livrables/Presentation_Soutenance_CongesFlow.pptx
+++ b/livrables/Presentation_Soutenance_CongesFlow.pptx
@@ -5062,7 +5062,7 @@
                 <a:ea typeface="Cambria" pitchFamily="34" charset="-122"/>
                 <a:cs typeface="Cambria" pitchFamily="34" charset="-120"/>
               </a:rPr>
-              <a:t>L'application en fonctionnement</a:t>
+              <a:t>L'application en ligne — congesflow-web.onrender.com</a:t>
             </a:r>
             <a:endParaRPr lang="en-US" sz="3000" dirty="0"/>
           </a:p>
@@ -5076,35 +5076,66 @@
         </p:nvSpPr>
         <p:spPr>
           <a:xfrm>
-            <a:off x="640080" y="1600200"/>
-            <a:ext cx="5394960" cy="2103120"/>
+            <a:off x="640080" y="1554480"/>
+            <a:ext cx="5394960" cy="2194560"/>
           </a:xfrm>
           <a:prstGeom prst="roundRect">
             <a:avLst>
-              <a:gd name="adj" fmla="val 2609"/>
+              <a:gd name="adj" fmla="val 3333"/>
             </a:avLst>
           </a:prstGeom>
           <a:solidFill>
-            <a:srgbClr val="F4F8FB"/>
+            <a:srgbClr val="EAF1F6"/>
           </a:solidFill>
-          <a:ln w="19050">
+          <a:ln w="12700">
             <a:solidFill>
-              <a:srgbClr val="0B5394"/>
+              <a:srgbClr val="DCE6EE"/>
             </a:solidFill>
-            <a:prstDash val="dash"/>
+            <a:prstDash val="solid"/>
           </a:ln>
-        </p:spPr>
-      </p:sp>
-      <p:sp>
-        <p:nvSpPr>
-          <p:cNvPr id="5" name="Text 3"/>
-          <p:cNvSpPr/>
-          <p:nvPr/>
-        </p:nvSpPr>
-        <p:spPr>
-          <a:xfrm>
-            <a:off x="822960" y="1600200"/>
-            <a:ext cx="5029200" cy="2103120"/>
+          <a:effectLst>
+            <a:outerShdw sx="100000" sy="100000" kx="0" ky="0" algn="bl" rotWithShape="0" blurRad="76200" dist="25400" dir="5400000">
+              <a:srgbClr val="B9C6D2">
+                <a:alpha val="30000"/>
+              </a:srgbClr>
+            </a:outerShdw>
+          </a:effectLst>
+        </p:spPr>
+      </p:sp>
+      <p:pic>
+        <p:nvPicPr>
+          <p:cNvPr id="5" name="Image 0" descr="/Users/boungoumbimigloirebryan/Desktop/ProjetCda/docs/screenshots/fig13-login.png">    </p:cNvPr>
+          <p:cNvPicPr>
+            <a:picLocks noChangeAspect="1"/>
+          </p:cNvPicPr>
+          <p:nvPr/>
+        </p:nvPicPr>
+        <p:blipFill>
+          <a:blip r:embed="rId1"/>
+          <a:stretch>
+            <a:fillRect/>
+          </a:stretch>
+        </p:blipFill>
+        <p:spPr>
+          <a:xfrm>
+            <a:off x="1947672" y="1664208"/>
+            <a:ext cx="2779776" cy="1737360"/>
+          </a:xfrm>
+          <a:prstGeom prst="rect">
+            <a:avLst/>
+          </a:prstGeom>
+        </p:spPr>
+      </p:pic>
+      <p:sp>
+        <p:nvSpPr>
+          <p:cNvPr id="6" name="Text 3"/>
+          <p:cNvSpPr/>
+          <p:nvPr/>
+        </p:nvSpPr>
+        <p:spPr>
+          <a:xfrm>
+            <a:off x="640080" y="3383280"/>
+            <a:ext cx="5394960" cy="274320"/>
           </a:xfrm>
           <a:prstGeom prst="rect">
             <a:avLst/>
@@ -5120,72 +5151,88 @@
               <a:buNone/>
             </a:pPr>
             <a:r>
-              <a:rPr lang="en-US" sz="1400" b="1" dirty="0">
-                <a:solidFill>
-                  <a:srgbClr val="0B5394"/>
-                </a:solidFill>
-                <a:latin typeface="Calibri" pitchFamily="34" charset="0"/>
-                <a:ea typeface="Calibri" pitchFamily="34" charset="-122"/>
-                <a:cs typeface="Calibri" pitchFamily="34" charset="-120"/>
-              </a:rPr>
-              <a:t>📷 CAPTURE D'ÉCRAN À INSÉRER
-</a:t>
-            </a:r>
-            <a:pPr algn="ctr" indent="0" marL="0">
-              <a:buNone/>
-            </a:pPr>
-            <a:r>
-              <a:rPr lang="en-US" sz="1100" i="1" dirty="0">
-                <a:solidFill>
-                  <a:srgbClr val="5B6B7B"/>
-                </a:solidFill>
-                <a:latin typeface="Calibri" pitchFamily="34" charset="0"/>
-                <a:ea typeface="Calibri" pitchFamily="34" charset="-122"/>
-                <a:cs typeface="Calibri" pitchFamily="34" charset="-120"/>
-              </a:rPr>
-              <a:t>Écran de connexion</a:t>
-            </a:r>
-            <a:endParaRPr lang="en-US" sz="1400" dirty="0"/>
-          </a:p>
-        </p:txBody>
-      </p:sp>
-      <p:sp>
-        <p:nvSpPr>
-          <p:cNvPr id="6" name="Shape 4"/>
-          <p:cNvSpPr/>
-          <p:nvPr/>
-        </p:nvSpPr>
-        <p:spPr>
-          <a:xfrm>
-            <a:off x="6126480" y="1600200"/>
-            <a:ext cx="5394960" cy="2103120"/>
+              <a:rPr lang="en-US" sz="1200" b="1" dirty="0">
+                <a:solidFill>
+                  <a:srgbClr val="1B2A3A"/>
+                </a:solidFill>
+                <a:latin typeface="Calibri" pitchFamily="34" charset="0"/>
+                <a:ea typeface="Calibri" pitchFamily="34" charset="-122"/>
+                <a:cs typeface="Calibri" pitchFamily="34" charset="-120"/>
+              </a:rPr>
+              <a:t>Connexion</a:t>
+            </a:r>
+            <a:endParaRPr lang="en-US" sz="1200" dirty="0"/>
+          </a:p>
+        </p:txBody>
+      </p:sp>
+      <p:sp>
+        <p:nvSpPr>
+          <p:cNvPr id="7" name="Shape 4"/>
+          <p:cNvSpPr/>
+          <p:nvPr/>
+        </p:nvSpPr>
+        <p:spPr>
+          <a:xfrm>
+            <a:off x="6126480" y="1554480"/>
+            <a:ext cx="5394960" cy="2194560"/>
           </a:xfrm>
           <a:prstGeom prst="roundRect">
             <a:avLst>
-              <a:gd name="adj" fmla="val 2609"/>
+              <a:gd name="adj" fmla="val 3333"/>
             </a:avLst>
           </a:prstGeom>
           <a:solidFill>
-            <a:srgbClr val="F4F8FB"/>
+            <a:srgbClr val="EAF1F6"/>
           </a:solidFill>
-          <a:ln w="19050">
+          <a:ln w="12700">
             <a:solidFill>
-              <a:srgbClr val="0B5394"/>
+              <a:srgbClr val="DCE6EE"/>
             </a:solidFill>
-            <a:prstDash val="dash"/>
+            <a:prstDash val="solid"/>
           </a:ln>
-        </p:spPr>
-      </p:sp>
-      <p:sp>
-        <p:nvSpPr>
-          <p:cNvPr id="7" name="Text 5"/>
-          <p:cNvSpPr/>
-          <p:nvPr/>
-        </p:nvSpPr>
-        <p:spPr>
-          <a:xfrm>
-            <a:off x="6309360" y="1600200"/>
-            <a:ext cx="5029200" cy="2103120"/>
+          <a:effectLst>
+            <a:outerShdw sx="100000" sy="100000" kx="0" ky="0" algn="bl" rotWithShape="0" blurRad="76200" dist="25400" dir="5400000">
+              <a:srgbClr val="B9C6D2">
+                <a:alpha val="30000"/>
+              </a:srgbClr>
+            </a:outerShdw>
+          </a:effectLst>
+        </p:spPr>
+      </p:sp>
+      <p:pic>
+        <p:nvPicPr>
+          <p:cNvPr id="8" name="Image 1" descr="/Users/boungoumbimigloirebryan/Desktop/ProjetCda/docs/screenshots/fig14-mes-demandes.png">    </p:cNvPr>
+          <p:cNvPicPr>
+            <a:picLocks noChangeAspect="1"/>
+          </p:cNvPicPr>
+          <p:nvPr/>
+        </p:nvPicPr>
+        <p:blipFill>
+          <a:blip r:embed="rId2"/>
+          <a:stretch>
+            <a:fillRect/>
+          </a:stretch>
+        </p:blipFill>
+        <p:spPr>
+          <a:xfrm>
+            <a:off x="7555300" y="1664208"/>
+            <a:ext cx="2537321" cy="1737360"/>
+          </a:xfrm>
+          <a:prstGeom prst="rect">
+            <a:avLst/>
+          </a:prstGeom>
+        </p:spPr>
+      </p:pic>
+      <p:sp>
+        <p:nvSpPr>
+          <p:cNvPr id="9" name="Text 5"/>
+          <p:cNvSpPr/>
+          <p:nvPr/>
+        </p:nvSpPr>
+        <p:spPr>
+          <a:xfrm>
+            <a:off x="6126480" y="3383280"/>
+            <a:ext cx="5394960" cy="274320"/>
           </a:xfrm>
           <a:prstGeom prst="rect">
             <a:avLst/>
@@ -5201,72 +5248,88 @@
               <a:buNone/>
             </a:pPr>
             <a:r>
-              <a:rPr lang="en-US" sz="1400" b="1" dirty="0">
-                <a:solidFill>
-                  <a:srgbClr val="0B5394"/>
-                </a:solidFill>
-                <a:latin typeface="Calibri" pitchFamily="34" charset="0"/>
-                <a:ea typeface="Calibri" pitchFamily="34" charset="-122"/>
-                <a:cs typeface="Calibri" pitchFamily="34" charset="-120"/>
-              </a:rPr>
-              <a:t>📷 CAPTURE D'ÉCRAN À INSÉRER
-</a:t>
-            </a:r>
-            <a:pPr algn="ctr" indent="0" marL="0">
-              <a:buNone/>
-            </a:pPr>
-            <a:r>
-              <a:rPr lang="en-US" sz="1100" i="1" dirty="0">
-                <a:solidFill>
-                  <a:srgbClr val="5B6B7B"/>
-                </a:solidFill>
-                <a:latin typeface="Calibri" pitchFamily="34" charset="0"/>
-                <a:ea typeface="Calibri" pitchFamily="34" charset="-122"/>
-                <a:cs typeface="Calibri" pitchFamily="34" charset="-120"/>
-              </a:rPr>
-              <a:t>Tableau de bord salarié (soldes + demande)</a:t>
-            </a:r>
-            <a:endParaRPr lang="en-US" sz="1400" dirty="0"/>
-          </a:p>
-        </p:txBody>
-      </p:sp>
-      <p:sp>
-        <p:nvSpPr>
-          <p:cNvPr id="8" name="Shape 6"/>
-          <p:cNvSpPr/>
-          <p:nvPr/>
-        </p:nvSpPr>
-        <p:spPr>
-          <a:xfrm>
-            <a:off x="640080" y="3886200"/>
-            <a:ext cx="5394960" cy="2103120"/>
+              <a:rPr lang="en-US" sz="1200" b="1" dirty="0">
+                <a:solidFill>
+                  <a:srgbClr val="1B2A3A"/>
+                </a:solidFill>
+                <a:latin typeface="Calibri" pitchFamily="34" charset="0"/>
+                <a:ea typeface="Calibri" pitchFamily="34" charset="-122"/>
+                <a:cs typeface="Calibri" pitchFamily="34" charset="-120"/>
+              </a:rPr>
+              <a:t>Espace salarié</a:t>
+            </a:r>
+            <a:endParaRPr lang="en-US" sz="1200" dirty="0"/>
+          </a:p>
+        </p:txBody>
+      </p:sp>
+      <p:sp>
+        <p:nvSpPr>
+          <p:cNvPr id="10" name="Shape 6"/>
+          <p:cNvSpPr/>
+          <p:nvPr/>
+        </p:nvSpPr>
+        <p:spPr>
+          <a:xfrm>
+            <a:off x="640080" y="3840480"/>
+            <a:ext cx="5394960" cy="2194560"/>
           </a:xfrm>
           <a:prstGeom prst="roundRect">
             <a:avLst>
-              <a:gd name="adj" fmla="val 2609"/>
+              <a:gd name="adj" fmla="val 3333"/>
             </a:avLst>
           </a:prstGeom>
           <a:solidFill>
-            <a:srgbClr val="F4F8FB"/>
+            <a:srgbClr val="EAF1F6"/>
           </a:solidFill>
-          <a:ln w="19050">
+          <a:ln w="12700">
             <a:solidFill>
-              <a:srgbClr val="0B5394"/>
+              <a:srgbClr val="DCE6EE"/>
             </a:solidFill>
-            <a:prstDash val="dash"/>
+            <a:prstDash val="solid"/>
           </a:ln>
-        </p:spPr>
-      </p:sp>
-      <p:sp>
-        <p:nvSpPr>
-          <p:cNvPr id="9" name="Text 7"/>
-          <p:cNvSpPr/>
-          <p:nvPr/>
-        </p:nvSpPr>
-        <p:spPr>
-          <a:xfrm>
-            <a:off x="822960" y="3886200"/>
-            <a:ext cx="5029200" cy="2103120"/>
+          <a:effectLst>
+            <a:outerShdw sx="100000" sy="100000" kx="0" ky="0" algn="bl" rotWithShape="0" blurRad="76200" dist="25400" dir="5400000">
+              <a:srgbClr val="B9C6D2">
+                <a:alpha val="30000"/>
+              </a:srgbClr>
+            </a:outerShdw>
+          </a:effectLst>
+        </p:spPr>
+      </p:sp>
+      <p:pic>
+        <p:nvPicPr>
+          <p:cNvPr id="11" name="Image 2" descr="/Users/boungoumbimigloirebryan/Desktop/ProjetCda/docs/screenshots/fig15-validation.png">    </p:cNvPr>
+          <p:cNvPicPr>
+            <a:picLocks noChangeAspect="1"/>
+          </p:cNvPicPr>
+          <p:nvPr/>
+        </p:nvPicPr>
+        <p:blipFill>
+          <a:blip r:embed="rId3"/>
+          <a:stretch>
+            <a:fillRect/>
+          </a:stretch>
+        </p:blipFill>
+        <p:spPr>
+          <a:xfrm>
+            <a:off x="1947672" y="3950208"/>
+            <a:ext cx="2779776" cy="1737360"/>
+          </a:xfrm>
+          <a:prstGeom prst="rect">
+            <a:avLst/>
+          </a:prstGeom>
+        </p:spPr>
+      </p:pic>
+      <p:sp>
+        <p:nvSpPr>
+          <p:cNvPr id="12" name="Text 7"/>
+          <p:cNvSpPr/>
+          <p:nvPr/>
+        </p:nvSpPr>
+        <p:spPr>
+          <a:xfrm>
+            <a:off x="640080" y="5669280"/>
+            <a:ext cx="5394960" cy="274320"/>
           </a:xfrm>
           <a:prstGeom prst="rect">
             <a:avLst/>
@@ -5282,72 +5345,88 @@
               <a:buNone/>
             </a:pPr>
             <a:r>
-              <a:rPr lang="en-US" sz="1400" b="1" dirty="0">
-                <a:solidFill>
-                  <a:srgbClr val="0B5394"/>
-                </a:solidFill>
-                <a:latin typeface="Calibri" pitchFamily="34" charset="0"/>
-                <a:ea typeface="Calibri" pitchFamily="34" charset="-122"/>
-                <a:cs typeface="Calibri" pitchFamily="34" charset="-120"/>
-              </a:rPr>
-              <a:t>📷 CAPTURE D'ÉCRAN À INSÉRER
-</a:t>
-            </a:r>
-            <a:pPr algn="ctr" indent="0" marL="0">
-              <a:buNone/>
-            </a:pPr>
-            <a:r>
-              <a:rPr lang="en-US" sz="1100" i="1" dirty="0">
-                <a:solidFill>
-                  <a:srgbClr val="5B6B7B"/>
-                </a:solidFill>
-                <a:latin typeface="Calibri" pitchFamily="34" charset="0"/>
-                <a:ea typeface="Calibri" pitchFamily="34" charset="-122"/>
-                <a:cs typeface="Calibri" pitchFamily="34" charset="-120"/>
-              </a:rPr>
-              <a:t>Espace de validation manager</a:t>
-            </a:r>
-            <a:endParaRPr lang="en-US" sz="1400" dirty="0"/>
-          </a:p>
-        </p:txBody>
-      </p:sp>
-      <p:sp>
-        <p:nvSpPr>
-          <p:cNvPr id="10" name="Shape 8"/>
-          <p:cNvSpPr/>
-          <p:nvPr/>
-        </p:nvSpPr>
-        <p:spPr>
-          <a:xfrm>
-            <a:off x="6126480" y="3886200"/>
-            <a:ext cx="5394960" cy="2103120"/>
+              <a:rPr lang="en-US" sz="1200" b="1" dirty="0">
+                <a:solidFill>
+                  <a:srgbClr val="1B2A3A"/>
+                </a:solidFill>
+                <a:latin typeface="Calibri" pitchFamily="34" charset="0"/>
+                <a:ea typeface="Calibri" pitchFamily="34" charset="-122"/>
+                <a:cs typeface="Calibri" pitchFamily="34" charset="-120"/>
+              </a:rPr>
+              <a:t>Validation manager</a:t>
+            </a:r>
+            <a:endParaRPr lang="en-US" sz="1200" dirty="0"/>
+          </a:p>
+        </p:txBody>
+      </p:sp>
+      <p:sp>
+        <p:nvSpPr>
+          <p:cNvPr id="13" name="Shape 8"/>
+          <p:cNvSpPr/>
+          <p:nvPr/>
+        </p:nvSpPr>
+        <p:spPr>
+          <a:xfrm>
+            <a:off x="6126480" y="3840480"/>
+            <a:ext cx="5394960" cy="2194560"/>
           </a:xfrm>
           <a:prstGeom prst="roundRect">
             <a:avLst>
-              <a:gd name="adj" fmla="val 2609"/>
+              <a:gd name="adj" fmla="val 3333"/>
             </a:avLst>
           </a:prstGeom>
           <a:solidFill>
-            <a:srgbClr val="F4F8FB"/>
+            <a:srgbClr val="EAF1F6"/>
           </a:solidFill>
-          <a:ln w="19050">
+          <a:ln w="12700">
             <a:solidFill>
-              <a:srgbClr val="0B5394"/>
+              <a:srgbClr val="DCE6EE"/>
             </a:solidFill>
-            <a:prstDash val="dash"/>
+            <a:prstDash val="solid"/>
           </a:ln>
-        </p:spPr>
-      </p:sp>
-      <p:sp>
-        <p:nvSpPr>
-          <p:cNvPr id="11" name="Text 9"/>
-          <p:cNvSpPr/>
-          <p:nvPr/>
-        </p:nvSpPr>
-        <p:spPr>
-          <a:xfrm>
-            <a:off x="6309360" y="3886200"/>
-            <a:ext cx="5029200" cy="2103120"/>
+          <a:effectLst>
+            <a:outerShdw sx="100000" sy="100000" kx="0" ky="0" algn="bl" rotWithShape="0" blurRad="76200" dist="25400" dir="5400000">
+              <a:srgbClr val="B9C6D2">
+                <a:alpha val="30000"/>
+              </a:srgbClr>
+            </a:outerShdw>
+          </a:effectLst>
+        </p:spPr>
+      </p:sp>
+      <p:pic>
+        <p:nvPicPr>
+          <p:cNvPr id="14" name="Image 3" descr="/Users/boungoumbimigloirebryan/Desktop/ProjetCda/docs/screenshots/fig16-dashboard.png">    </p:cNvPr>
+          <p:cNvPicPr>
+            <a:picLocks noChangeAspect="1"/>
+          </p:cNvPicPr>
+          <p:nvPr/>
+        </p:nvPicPr>
+        <p:blipFill>
+          <a:blip r:embed="rId4"/>
+          <a:stretch>
+            <a:fillRect/>
+          </a:stretch>
+        </p:blipFill>
+        <p:spPr>
+          <a:xfrm>
+            <a:off x="7434072" y="3950208"/>
+            <a:ext cx="2779776" cy="1737360"/>
+          </a:xfrm>
+          <a:prstGeom prst="rect">
+            <a:avLst/>
+          </a:prstGeom>
+        </p:spPr>
+      </p:pic>
+      <p:sp>
+        <p:nvSpPr>
+          <p:cNvPr id="15" name="Text 9"/>
+          <p:cNvSpPr/>
+          <p:nvPr/>
+        </p:nvSpPr>
+        <p:spPr>
+          <a:xfrm>
+            <a:off x="6126480" y="5669280"/>
+            <a:ext cx="5394960" cy="274320"/>
           </a:xfrm>
           <a:prstGeom prst="rect">
             <a:avLst/>
@@ -5363,32 +5442,17 @@
               <a:buNone/>
             </a:pPr>
             <a:r>
-              <a:rPr lang="en-US" sz="1400" b="1" dirty="0">
-                <a:solidFill>
-                  <a:srgbClr val="0B5394"/>
-                </a:solidFill>
-                <a:latin typeface="Calibri" pitchFamily="34" charset="0"/>
-                <a:ea typeface="Calibri" pitchFamily="34" charset="-122"/>
-                <a:cs typeface="Calibri" pitchFamily="34" charset="-120"/>
-              </a:rPr>
-              <a:t>📷 CAPTURE D'ÉCRAN À INSÉRER
-</a:t>
-            </a:r>
-            <a:pPr algn="ctr" indent="0" marL="0">
-              <a:buNone/>
-            </a:pPr>
-            <a:r>
-              <a:rPr lang="en-US" sz="1100" i="1" dirty="0">
-                <a:solidFill>
-                  <a:srgbClr val="5B6B7B"/>
-                </a:solidFill>
-                <a:latin typeface="Calibri" pitchFamily="34" charset="0"/>
-                <a:ea typeface="Calibri" pitchFamily="34" charset="-122"/>
-                <a:cs typeface="Calibri" pitchFamily="34" charset="-120"/>
-              </a:rPr>
-              <a:t>Documentation Swagger de l'API</a:t>
-            </a:r>
-            <a:endParaRPr lang="en-US" sz="1400" dirty="0"/>
+              <a:rPr lang="en-US" sz="1200" b="1" dirty="0">
+                <a:solidFill>
+                  <a:srgbClr val="1B2A3A"/>
+                </a:solidFill>
+                <a:latin typeface="Calibri" pitchFamily="34" charset="0"/>
+                <a:ea typeface="Calibri" pitchFamily="34" charset="-122"/>
+                <a:cs typeface="Calibri" pitchFamily="34" charset="-120"/>
+              </a:rPr>
+              <a:t>Tableau de bord</a:t>
+            </a:r>
+            <a:endParaRPr lang="en-US" sz="1200" dirty="0"/>
           </a:p>
         </p:txBody>
       </p:sp>
@@ -7479,7 +7543,7 @@
                 <a:ea typeface="Calibri" pitchFamily="34" charset="-122"/>
                 <a:cs typeface="Calibri" pitchFamily="34" charset="-120"/>
               </a:rPr>
-              <a:t>CongésFlow · Démo : http://localhost:5173 · Dépôt : [lien GitHub]</a:t>
+              <a:t>App : congesflow-web.onrender.com   ·   Code : github.com/glo007/congesflow</a:t>
             </a:r>
             <a:endParaRPr lang="en-US" sz="1300" dirty="0"/>
           </a:p>

</xml_diff>

<commit_message>
Documents : insertion du nom (BOUNGOU MBIMI Gloire Bryan), ville et période
</commit_message>
<xml_diff>
--- a/livrables/Presentation_Soutenance_CongesFlow.pptx
+++ b/livrables/Presentation_Soutenance_CongesFlow.pptx
@@ -2685,7 +2685,7 @@
                 <a:ea typeface="Calibri" pitchFamily="34" charset="-122"/>
                 <a:cs typeface="Calibri" pitchFamily="34" charset="-120"/>
               </a:rPr>
-              <a:t>[Votre Nom Prénom]  ·  Encadrant : M'hand BOUFALA</a:t>
+              <a:t>BOUNGOU MBIMI Gloire Bryan  ·  Encadrant : M'hand BOUFALA</a:t>
             </a:r>
             <a:endParaRPr lang="en-US" sz="1300" dirty="0"/>
           </a:p>
@@ -5215,8 +5215,8 @@
         </p:blipFill>
         <p:spPr>
           <a:xfrm>
-            <a:off x="7555300" y="1664208"/>
-            <a:ext cx="2537321" cy="1737360"/>
+            <a:off x="7610673" y="1664208"/>
+            <a:ext cx="2426575" cy="1737360"/>
           </a:xfrm>
           <a:prstGeom prst="rect">
             <a:avLst/>

</xml_diff>